<commit_message>
Push Canvas Rubric structure mapping -> ITAI 1378 Midterm_DenisAosaSafetycoordinatorGlasses/docs/MD_Aosa_Denis_ITAI1378.pptx
</commit_message>
<xml_diff>
--- a/ITAI 1378 Midterm_DenisAosaSafetycoordinatorGlasses/docs/MD_Aosa_Denis_ITAI1378.pptx
+++ b/ITAI 1378 Midterm_DenisAosaSafetycoordinatorGlasses/docs/MD_Aosa_Denis_ITAI1378.pptx
@@ -3322,7 +3322,7 @@
               <a:defRPr sz="2000"/>
             </a:pPr>
             <a:r>
-              <a:t>Delivery drivers (like Amazon DSPs) face unpredictably dangerous 'Last 100 Yards' conditions. Trips on broken stairs, loose pets, and poor back mechanics cause frequent injuries.</a:t>
+              <a:t>Logistics workers face constant dangers. Delivery drivers endure hazardous 'Last 100 Yards' conditions (stairs, pets), while warehouse workers risk catastrophic forklift collisions and improper lifting injuries.</a:t>
             </a:r>
           </a:p>
           <a:p>
@@ -3343,7 +3343,7 @@
               <a:defRPr sz="2000"/>
             </a:pPr>
             <a:r>
-              <a:t>Logistics companies, Delivery Drivers, Supply Chain Managers.</a:t>
+              <a:t>Supply Chain Managers, Warehouse Supervisors, OSHA, and Delivery DSPs.</a:t>
             </a:r>
           </a:p>
           <a:p>
@@ -3364,7 +3364,7 @@
               <a:defRPr sz="2000"/>
             </a:pPr>
             <a:r>
-              <a:t>Accidents and injuries cost thousands annually per incident in compensation and delay crucial deliveries.</a:t>
+              <a:t>Accidents result in severe injuries, lawsuits, and thousands of dollars in medical compensation and lost productivity.</a:t>
             </a:r>
           </a:p>
         </p:txBody>
@@ -3432,7 +3432,7 @@
               <a:defRPr sz="2000"/>
             </a:pPr>
             <a:r>
-              <a:t>A wearable smart-glasses CV system that evaluates real-time camera feeds to alert delivery drivers of high-risk situations.</a:t>
+              <a:t>A wearable smart-glasses CV system that evaluates real-time camera feeds to alert logistics staff of high-risk situations.</a:t>
             </a:r>
           </a:p>
           <a:p>
@@ -3453,7 +3453,7 @@
               <a:defRPr sz="2000"/>
             </a:pPr>
             <a:r>
-              <a:t>It identifies critical hazards (stairs, pets) and monitors spinal posture via camera, triggering a 'Stop &amp; Assess' HUD visual to prevent accidents and promote safe lifting mechanics.</a:t>
+              <a:t>It identifies critical hazards (forklifts, stairs) and monitors spinal posture, triggering a 'Stop &amp; Assess' HUD visual to prevent collisions, falls, and ergonomic injuries.</a:t>
             </a:r>
           </a:p>
         </p:txBody>
@@ -3620,7 +3620,7 @@
               <a:defRPr sz="2000"/>
             </a:pPr>
             <a:r>
-              <a:t>Roboflow Universe (e.g., 'Residential Delivery Hazards' dataset).</a:t>
+              <a:t>Roboflow Universe ('Warehouse Safety' and 'Residential Delivery Hazards' datasets).</a:t>
             </a:r>
           </a:p>
           <a:p>
@@ -3641,7 +3641,7 @@
               <a:defRPr sz="2000"/>
             </a:pPr>
             <a:r>
-              <a:t>Roughly 1,500 annotated images of porches, steps, and dogs.</a:t>
+              <a:t>Roughly 2,000 annotated images of forklifts, porches, steps, and dogs.</a:t>
             </a:r>
           </a:p>
           <a:p>
@@ -3662,7 +3662,7 @@
               <a:defRPr sz="2000"/>
             </a:pPr>
             <a:r>
-              <a:t>Bounding boxes for: loose_pet, broken_stairs, low_obstacle, trip_wire.</a:t>
+              <a:t>Bounding boxes for: forklift, loose_pet, broken_stairs, low_obstacle.</a:t>
             </a:r>
           </a:p>
           <a:p>
@@ -3683,7 +3683,7 @@
               <a:defRPr sz="2000"/>
             </a:pPr>
             <a:r>
-              <a:t>Standardize resolution to 640x640 and apply minor augmentations (brightness changes for porch lighting variance).</a:t>
+              <a:t>Standardize resolution to 640x640 and apply minor augmentations (brightness changes for warehouse/porch lighting variance).</a:t>
             </a:r>
           </a:p>
         </p:txBody>
@@ -3824,7 +3824,7 @@
               <a:defRPr sz="2000"/>
             </a:pPr>
             <a:r>
-              <a:t>Target: ≥ 95% (False positives are annoying, but false negatives cause injuries).</a:t>
+              <a:t>Target: ≥ 95% (False positives are annoying, but missing a forklift is deadly).</a:t>
             </a:r>
           </a:p>
           <a:p>
@@ -3845,7 +3845,7 @@
               <a:defRPr sz="2000"/>
             </a:pPr>
             <a:r>
-              <a:t>Target: &lt; 30ms per frame to provide real-time 'Stop &amp; Assess' warnings before the driver takes a step.</a:t>
+              <a:t>Target: &lt; 30ms per frame to provide real-time 'Stop &amp; Assess' warnings before collisions occur.</a:t>
             </a:r>
           </a:p>
         </p:txBody>
@@ -4005,15 +4005,15 @@
           <a:lstStyle/>
           <a:p>
             <a:r>
-              <a:t>Challenge: Not enough 'hazardous porch' variation in public data.</a:t>
-            </a:r>
-          </a:p>
-          <a:p>
-            <a:pPr>
-              <a:defRPr sz="2000"/>
-            </a:pPr>
-            <a:r>
-              <a:t>Plan B: Use stable diffusion or synthetic renders (e.g., Carla simulator) to generate dangerous porch environments.</a:t>
+              <a:t>Challenge: Not enough 'hazardous' variation in public data (e.g. rare forklift crashes).</a:t>
+            </a:r>
+          </a:p>
+          <a:p>
+            <a:pPr>
+              <a:defRPr sz="2000"/>
+            </a:pPr>
+            <a:r>
+              <a:t>Plan B: Use stable diffusion or synthetic renders (e.g., Carla simulator) to generate dangerous warehouse/porch environments.</a:t>
             </a:r>
           </a:p>
           <a:p>

</xml_diff>